<commit_message>
actualizado actions a 2026
</commit_message>
<xml_diff>
--- a/docs/tema0/diapositivas/github-actions.pptx
+++ b/docs/tema0/diapositivas/github-actions.pptx
@@ -3898,7 +3898,7 @@
                 <a:ea typeface="Arial" pitchFamily="34" charset="-122"/>
                 <a:cs typeface="Arial" pitchFamily="34" charset="-120"/>
               </a:rPr>
-              <a:t>Step 1 — checkout@v4</a:t>
+              <a:t>Step 1 — checkout@v7</a:t>
             </a:r>
             <a:endParaRPr lang="en-US" sz="1500" dirty="0"/>
           </a:p>
@@ -3939,7 +3939,7 @@
                 <a:ea typeface="Arial" pitchFamily="34" charset="-122"/>
                 <a:cs typeface="Arial" pitchFamily="34" charset="-120"/>
               </a:rPr>
-              <a:t>Step 2 — setup-java@v4</a:t>
+              <a:t>Step 2 — setup-java@v6</a:t>
             </a:r>
             <a:endParaRPr lang="en-US" sz="1500" dirty="0"/>
           </a:p>
@@ -6646,7 +6646,7 @@
           <p:nvPr>
             <p:extLst>
               <p:ext uri="{D42A27DB-BD31-4B8C-83A1-F6EECF244321}">
-                <p14:modId xmlns:p14="http://schemas.microsoft.com/office/powerpoint/2010/main" val="1579011935"/>
+                <p14:modId xmlns:p14="http://schemas.microsoft.com/office/powerpoint/2010/main" val="2316651001"/>
               </p:ext>
             </p:extLst>
           </p:nvPr>
@@ -6836,7 +6836,7 @@
                           <a:ea typeface="Arial" pitchFamily="34" charset="-122"/>
                           <a:cs typeface="Arial" pitchFamily="34" charset="-120"/>
                         </a:rPr>
-                        <a:t>actions/checkout@v4</a:t>
+                        <a:t>actions/checkout@v7</a:t>
                       </a:r>
                       <a:endParaRPr lang="en-US" sz="1400" dirty="0">
                         <a:latin typeface="Arial" charset="0"/>
@@ -6979,7 +6979,7 @@
                           <a:ea typeface="Arial" pitchFamily="34" charset="-122"/>
                           <a:cs typeface="Arial" pitchFamily="34" charset="-120"/>
                         </a:rPr>
-                        <a:t>actions/setup-java@v4</a:t>
+                        <a:t>actions/setup-java@v6</a:t>
                       </a:r>
                       <a:endParaRPr lang="en-US" sz="1400" dirty="0">
                         <a:latin typeface="Arial" charset="0"/>
@@ -7122,7 +7122,7 @@
                           <a:ea typeface="Arial" pitchFamily="34" charset="-122"/>
                           <a:cs typeface="Arial" pitchFamily="34" charset="-120"/>
                         </a:rPr>
-                        <a:t>actions/setup-node@v4</a:t>
+                        <a:t>actions/setup-node@v7</a:t>
                       </a:r>
                       <a:endParaRPr lang="en-US" sz="1400" dirty="0">
                         <a:latin typeface="Arial" charset="0"/>
@@ -7265,7 +7265,7 @@
                           <a:ea typeface="Arial" pitchFamily="34" charset="-122"/>
                           <a:cs typeface="Arial" pitchFamily="34" charset="-120"/>
                         </a:rPr>
-                        <a:t>actions/cache@v4</a:t>
+                        <a:t>actions/cache@v6</a:t>
                       </a:r>
                       <a:endParaRPr lang="en-US" sz="1400" dirty="0">
                         <a:latin typeface="Arial" charset="0"/>
@@ -7408,7 +7408,18 @@
                           <a:ea typeface="Arial" pitchFamily="34" charset="-122"/>
                           <a:cs typeface="Arial" pitchFamily="34" charset="-120"/>
                         </a:rPr>
-                        <a:t>actions/upload-artifact@v4</a:t>
+                        <a:t>actions/upload-artifact</a:t>
+                      </a:r>
+                      <a:r>
+                        <a:rPr lang="en-US" sz="1400" b="1">
+                          <a:solidFill>
+                            <a:srgbClr val="212121"/>
+                          </a:solidFill>
+                          <a:latin typeface="Arial" pitchFamily="34" charset="0"/>
+                          <a:ea typeface="Arial" pitchFamily="34" charset="-122"/>
+                          <a:cs typeface="Arial" pitchFamily="34" charset="-120"/>
+                        </a:rPr>
+                        <a:t>@v7</a:t>
                       </a:r>
                       <a:endParaRPr lang="en-US" sz="1400" dirty="0">
                         <a:latin typeface="Arial" charset="0"/>
@@ -14177,7 +14188,7 @@
                 <a:ea typeface="Courier New" pitchFamily="34" charset="-122"/>
                 <a:cs typeface="Courier New" pitchFamily="34" charset="-120"/>
               </a:rPr>
-              <a:t>        uses: actions/checkout@v4</a:t>
+              <a:t>        uses: actions/checkout@v7</a:t>
             </a:r>
             <a:endParaRPr lang="en-US" sz="1200" dirty="0"/>
           </a:p>
@@ -14217,7 +14228,7 @@
                 <a:ea typeface="Courier New" pitchFamily="34" charset="-122"/>
                 <a:cs typeface="Courier New" pitchFamily="34" charset="-120"/>
               </a:rPr>
-              <a:t>        uses: actions/setup-java@v4</a:t>
+              <a:t>        uses: actions/setup-java@v6</a:t>
             </a:r>
             <a:endParaRPr lang="en-US" sz="1200" dirty="0"/>
           </a:p>
@@ -14422,7 +14433,7 @@
                 <a:ea typeface="Courier New" pitchFamily="34" charset="-122"/>
                 <a:cs typeface="Courier New" pitchFamily="34" charset="-120"/>
               </a:rPr>
-              <a:t>        uses: actions/upload-artifact@v4</a:t>
+              <a:t>        uses: actions/upload-artifact@v7</a:t>
             </a:r>
             <a:endParaRPr lang="en-US" sz="1200" dirty="0"/>
           </a:p>

</xml_diff>